<commit_message>
Release public package v2.0.0
</commit_message>
<xml_diff>
--- a/slides/Internal Advocacy Deck - Paired Engineering with AI.pptx
+++ b/slides/Internal Advocacy Deck - Paired Engineering with AI.pptx
@@ -1115,7 +1115,7 @@
           </a:p>
           <a:p>
             <a:r>
-              <a:t>Close by pointing people to the next layer. This deck should create interest and alignment, not try to teach the full operating model in one brown-bag session.</a:t>
+              <a:t>Close by pointing people to the next layer. This deck should create interest and alignment, not try to teach the full delivery model in one brown-bag session.</a:t>
             </a:r>
           </a:p>
         </p:txBody>
@@ -4198,7 +4198,7 @@
                 </a:solidFill>
                 <a:latin typeface="Aptos"/>
               </a:rPr>
-              <a:t>A practical operating model for AI enablement in software delivery</a:t>
+              <a:t>A practical delivery model for AI-enabled software teams</a:t>
             </a:r>
           </a:p>
         </p:txBody>
@@ -4362,7 +4362,7 @@
                 </a:solidFill>
                 <a:latin typeface="Aptos"/>
               </a:rPr>
-              <a:t>Paired Engineering. A practical operating model for AI enablement in software delivery.</a:t>
+              <a:t>Paired Engineering. A practical delivery model for AI-enabled software teams.</a:t>
             </a:r>
           </a:p>
         </p:txBody>
@@ -4724,7 +4724,7 @@
                 </a:solidFill>
                 <a:latin typeface="Aptos"/>
               </a:rPr>
-              <a:t>Paired Engineering. A practical operating model for AI enablement in software delivery.</a:t>
+              <a:t>Paired Engineering. A practical delivery model for AI-enabled software teams.</a:t>
             </a:r>
           </a:p>
         </p:txBody>
@@ -5047,7 +5047,7 @@
               </a:defRPr>
             </a:pPr>
             <a:r>
-              <a:t>- paired engineering is the useful middle path</a:t>
+              <a:t>- paired engineering is the more useful alternative</a:t>
             </a:r>
           </a:p>
         </p:txBody>
@@ -5125,7 +5125,7 @@
                 </a:solidFill>
                 <a:latin typeface="Aptos"/>
               </a:rPr>
-              <a:t>Paired Engineering. A practical operating model for AI enablement in software delivery.</a:t>
+              <a:t>Paired Engineering. A practical delivery model for AI-enabled software teams.</a:t>
             </a:r>
           </a:p>
         </p:txBody>
@@ -5526,7 +5526,7 @@
                 </a:solidFill>
                 <a:latin typeface="Aptos"/>
               </a:rPr>
-              <a:t>Paired Engineering. A practical operating model for AI enablement in software delivery.</a:t>
+              <a:t>Paired Engineering. A practical delivery model for AI-enabled software teams.</a:t>
             </a:r>
           </a:p>
         </p:txBody>
@@ -5996,7 +5996,7 @@
                 </a:solidFill>
                 <a:latin typeface="Aptos"/>
               </a:rPr>
-              <a:t>Paired Engineering. A practical operating model for AI enablement in software delivery.</a:t>
+              <a:t>Paired Engineering. A practical delivery model for AI-enabled software teams.</a:t>
             </a:r>
           </a:p>
         </p:txBody>
@@ -6420,7 +6420,7 @@
                 </a:solidFill>
                 <a:latin typeface="Aptos"/>
               </a:rPr>
-              <a:t>Paired Engineering. A practical operating model for AI enablement in software delivery.</a:t>
+              <a:t>Paired Engineering. A practical delivery model for AI-enabled software teams.</a:t>
             </a:r>
           </a:p>
         </p:txBody>
@@ -6844,7 +6844,7 @@
                 </a:solidFill>
                 <a:latin typeface="Aptos"/>
               </a:rPr>
-              <a:t>Paired Engineering. A practical operating model for AI enablement in software delivery.</a:t>
+              <a:t>Paired Engineering. A practical delivery model for AI-enabled software teams.</a:t>
             </a:r>
           </a:p>
         </p:txBody>
@@ -7245,7 +7245,7 @@
                 </a:solidFill>
                 <a:latin typeface="Aptos"/>
               </a:rPr>
-              <a:t>Paired Engineering. A practical operating model for AI enablement in software delivery.</a:t>
+              <a:t>Paired Engineering. A practical delivery model for AI-enabled software teams.</a:t>
             </a:r>
           </a:p>
         </p:txBody>
@@ -7669,7 +7669,7 @@
                 </a:solidFill>
                 <a:latin typeface="Aptos"/>
               </a:rPr>
-              <a:t>Paired Engineering. A practical operating model for AI enablement in software delivery.</a:t>
+              <a:t>Paired Engineering. A practical delivery model for AI-enabled software teams.</a:t>
             </a:r>
           </a:p>
         </p:txBody>

</xml_diff>